<commit_message>
Presentation: description du Switch mise a jour (point 4 du mentor)
</commit_message>
<xml_diff>
--- a/bottleneck_presentation.pptx
+++ b/bottleneck_presentation.pptx
@@ -2371,7 +2371,7 @@
                   <a:srgbClr val="4A3363"/>
                 </a:solidFill>
               </a:rPr>
-              <a:t>Impossible de faire lire au Switch une valeur calculée par un script — résolu en réutilisant le même mécanisme que pour les tests (error() + état de la tâche), plutôt qu'une nouvelle approche plus fragile</a:t>
+              <a:t>Impossible de faire lire au Switch une valeur calculée directement — résolu en séparant comptage (toujours réussi) et vérification (échoue si zéro), le Switch lisant l'état de la vérification</a:t>
             </a:r>
             <a:endParaRPr lang="en-US" sz="1050" dirty="0"/>
           </a:p>
@@ -5014,7 +5014,7 @@
             <a:r>
               <a:rPr lang="en-US" sz="1000" b="1" dirty="0">
                 <a:solidFill>
-                  <a:srgbClr val="FFFFFF"/>
+                  <a:srgbClr val="4A3363"/>
                 </a:solidFill>
               </a:rPr>
               <a:t>Rapport CA</a:t>
@@ -5028,7 +5028,7 @@
             <a:r>
               <a:rPr lang="en-US" sz="1000" b="1" dirty="0">
                 <a:solidFill>
-                  <a:srgbClr val="FFFFFF"/>
+                  <a:srgbClr val="4A3363"/>
                 </a:solidFill>
               </a:rPr>
               <a:t>(.xlsx)</a:t>
@@ -5091,7 +5091,7 @@
             <a:r>
               <a:rPr lang="en-US" sz="1000" b="1" dirty="0">
                 <a:solidFill>
-                  <a:srgbClr val="FFFFFF"/>
+                  <a:srgbClr val="4A3363"/>
                 </a:solidFill>
               </a:rPr>
               <a:t>Vins premium</a:t>
@@ -5105,7 +5105,7 @@
             <a:r>
               <a:rPr lang="en-US" sz="1000" b="1" dirty="0">
                 <a:solidFill>
-                  <a:srgbClr val="FFFFFF"/>
+                  <a:srgbClr val="4A3363"/>
                 </a:solidFill>
               </a:rPr>
               <a:t>(.csv)</a:t>
@@ -5168,7 +5168,7 @@
             <a:r>
               <a:rPr lang="en-US" sz="1000" b="1" dirty="0">
                 <a:solidFill>
-                  <a:srgbClr val="FFFFFF"/>
+                  <a:srgbClr val="4A3363"/>
                 </a:solidFill>
               </a:rPr>
               <a:t>Vins ordinaires</a:t>
@@ -5182,7 +5182,7 @@
             <a:r>
               <a:rPr lang="en-US" sz="1000" b="1" dirty="0">
                 <a:solidFill>
-                  <a:srgbClr val="FFFFFF"/>
+                  <a:srgbClr val="4A3363"/>
                 </a:solidFill>
               </a:rPr>
               <a:t>(.csv)</a:t>
@@ -5696,7 +5696,7 @@
                   <a:srgbClr val="4A3363"/>
                 </a:solidFill>
               </a:rPr>
-              <a:t>Un branchement conditionnel vérifie si des vins premium sont détectés : si oui, extraction des deux catégories ; sinon, extraction des ordinaires seuls + alerte</a:t>
+              <a:t>Un comptage des vins premium détectés décide du chemin : s'il y en a au moins un, extraction des deux catégories ; sinon, extraction des ordinaires seuls + alerte</a:t>
             </a:r>
             <a:endParaRPr lang="en-US" sz="1150" dirty="0"/>
           </a:p>
@@ -5811,7 +5811,7 @@
       </p:sp>
       <p:pic>
         <p:nvPicPr>
-          <p:cNvPr id="4" name="Image 0" descr="/home/claude/pptx_work2/topology_new.png">    </p:cNvPr>
+          <p:cNvPr id="4" name="Image 0" descr="/home/claude/pptx_work3/topology_new.png">    </p:cNvPr>
           <p:cNvPicPr>
             <a:picLocks noChangeAspect="1"/>
           </p:cNvPicPr>
@@ -5942,7 +5942,7 @@
       </p:sp>
       <p:pic>
         <p:nvPicPr>
-          <p:cNvPr id="4" name="Image 0" descr="/home/claude/pptx_work2/gantt_new.png">    </p:cNvPr>
+          <p:cNvPr id="4" name="Image 0" descr="/home/claude/pptx_work3/gantt_new.png">    </p:cNvPr>
           <p:cNvPicPr>
             <a:picLocks noChangeAspect="1"/>
           </p:cNvPicPr>
@@ -6084,7 +6084,7 @@
             <a:r>
               <a:rPr lang="en-US" sz="1400" b="1" dirty="0">
                 <a:solidFill>
-                  <a:srgbClr val="FFFFFF"/>
+                  <a:srgbClr val="4A3363"/>
                 </a:solidFill>
               </a:rPr>
               <a:t>✓</a:t>
@@ -6214,7 +6214,7 @@
             <a:r>
               <a:rPr lang="en-US" sz="1400" b="1" dirty="0">
                 <a:solidFill>
-                  <a:srgbClr val="FFFFFF"/>
+                  <a:srgbClr val="4A3363"/>
                 </a:solidFill>
               </a:rPr>
               <a:t>✓</a:t>
@@ -6344,7 +6344,7 @@
             <a:r>
               <a:rPr lang="en-US" sz="1400" b="1" dirty="0">
                 <a:solidFill>
-                  <a:srgbClr val="FFFFFF"/>
+                  <a:srgbClr val="4A3363"/>
                 </a:solidFill>
               </a:rPr>
               <a:t>✓</a:t>
@@ -6474,7 +6474,7 @@
             <a:r>
               <a:rPr lang="en-US" sz="1400" b="1" dirty="0">
                 <a:solidFill>
-                  <a:srgbClr val="FFFFFF"/>
+                  <a:srgbClr val="4A3363"/>
                 </a:solidFill>
               </a:rPr>
               <a:t>✓</a:t>
@@ -6604,7 +6604,7 @@
             <a:r>
               <a:rPr lang="en-US" sz="1400" b="1" dirty="0">
                 <a:solidFill>
-                  <a:srgbClr val="FFFFFF"/>
+                  <a:srgbClr val="4A3363"/>
                 </a:solidFill>
               </a:rPr>
               <a:t>✓</a:t>

</xml_diff>